<commit_message>
x402: multi-rail (BSC + Base) + default PayAI facilitator
</commit_message>
<xml_diff>
--- a/AXP_Investor_Deck.pptx
+++ b/AXP_Investor_Deck.pptx
@@ -8867,7 +8867,7 @@
                 <a:ea typeface="Calibri" pitchFamily="34" charset="-122"/>
                 <a:cs typeface="Calibri" pitchFamily="34" charset="-120"/>
               </a:rPr>
-              <a:t>Recurring. Where the durable, AWS-style revenue lives.</a:t>
+              <a:t>Slot-based: $9 = 1 agent, $29 = 5. Durable, AWS-style recurring.</a:t>
             </a:r>
             <a:endParaRPr lang="en-US" sz="1250" dirty="0"/>
           </a:p>
@@ -9138,7 +9138,7 @@
                 <a:ea typeface="Trebuchet MS" pitchFamily="34" charset="-122"/>
                 <a:cs typeface="Trebuchet MS" pitchFamily="34" charset="-120"/>
               </a:rPr>
-              <a:t>Trust API</a:t>
+              <a:t>Trust API + Scale</a:t>
             </a:r>
             <a:endParaRPr lang="en-US" sz="1600" dirty="0"/>
           </a:p>
@@ -9219,7 +9219,7 @@
                 <a:ea typeface="Calibri" pitchFamily="34" charset="-122"/>
                 <a:cs typeface="Calibri" pitchFamily="34" charset="-120"/>
               </a:rPr>
-              <a:t>Programmatic Trust Score, risk reports, best-agent matching.</a:t>
+              <a:t>Full data API + host up to 100 agents. Power-user / agency tier.</a:t>
             </a:r>
             <a:endParaRPr lang="en-US" sz="1250" dirty="0"/>
           </a:p>

</xml_diff>